<commit_message>
feat(harness): harden local model visual workflows
</commit_message>
<xml_diff>
--- a/docs/presentation/ionic-llm-harness-overview.pptx
+++ b/docs/presentation/ionic-llm-harness-overview.pptx
@@ -2,27 +2,27 @@
 <file path=ppt/presentation.xml><?xml version="1.0" encoding="utf-8"?>
 <p:presentation xmlns:p="http://schemas.openxmlformats.org/presentationml/2006/main">
   <p:sldMasterIdLst>
-    <p:sldMasterId xmlns:r="http://schemas.openxmlformats.org/officeDocument/2006/relationships" id="2147483648" r:id="R4419be23eb7b43f9"/>
+    <p:sldMasterId xmlns:r="http://schemas.openxmlformats.org/officeDocument/2006/relationships" id="2147483648" r:id="Rf30f4e3b4ae348a6"/>
   </p:sldMasterIdLst>
   <p:notesMasterIdLst>
-    <p:notesMasterId xmlns:r="http://schemas.openxmlformats.org/officeDocument/2006/relationships" r:id="Re528525d70b74199"/>
+    <p:notesMasterId xmlns:r="http://schemas.openxmlformats.org/officeDocument/2006/relationships" r:id="R051e53eb5a664916"/>
   </p:notesMasterIdLst>
   <p:sldIdLst>
-    <p:sldId xmlns:r="http://schemas.openxmlformats.org/officeDocument/2006/relationships" id="256" r:id="R0c9159ab98d44216"/>
-    <p:sldId xmlns:r="http://schemas.openxmlformats.org/officeDocument/2006/relationships" id="257" r:id="R09aeb56856d948b1"/>
-    <p:sldId xmlns:r="http://schemas.openxmlformats.org/officeDocument/2006/relationships" id="258" r:id="R8c6ec6f0531940c0"/>
-    <p:sldId xmlns:r="http://schemas.openxmlformats.org/officeDocument/2006/relationships" id="259" r:id="Rba7d5e70fea24dae"/>
-    <p:sldId xmlns:r="http://schemas.openxmlformats.org/officeDocument/2006/relationships" id="260" r:id="R828fa93fc7e14830"/>
-    <p:sldId xmlns:r="http://schemas.openxmlformats.org/officeDocument/2006/relationships" id="261" r:id="R1864f5f6501041ab"/>
-    <p:sldId xmlns:r="http://schemas.openxmlformats.org/officeDocument/2006/relationships" id="262" r:id="R296c607204d54dcc"/>
-    <p:sldId xmlns:r="http://schemas.openxmlformats.org/officeDocument/2006/relationships" id="263" r:id="R5d530053b10b4746"/>
-    <p:sldId xmlns:r="http://schemas.openxmlformats.org/officeDocument/2006/relationships" id="264" r:id="R30134c09e9ab431b"/>
-    <p:sldId xmlns:r="http://schemas.openxmlformats.org/officeDocument/2006/relationships" id="265" r:id="R3ceeb0d9fa3c4bb5"/>
-    <p:sldId xmlns:r="http://schemas.openxmlformats.org/officeDocument/2006/relationships" id="266" r:id="R3465c8a160dd4ae3"/>
-    <p:sldId xmlns:r="http://schemas.openxmlformats.org/officeDocument/2006/relationships" id="267" r:id="R8d44051821354156"/>
-    <p:sldId xmlns:r="http://schemas.openxmlformats.org/officeDocument/2006/relationships" id="268" r:id="Ra0f3076433dc4cab"/>
-    <p:sldId xmlns:r="http://schemas.openxmlformats.org/officeDocument/2006/relationships" id="269" r:id="Rc2bce0b4036c498b"/>
-    <p:sldId xmlns:r="http://schemas.openxmlformats.org/officeDocument/2006/relationships" id="270" r:id="R12932e3fd2a14687"/>
+    <p:sldId xmlns:r="http://schemas.openxmlformats.org/officeDocument/2006/relationships" id="256" r:id="Rd6098978ccd9421a"/>
+    <p:sldId xmlns:r="http://schemas.openxmlformats.org/officeDocument/2006/relationships" id="257" r:id="R6c138e739bef4d59"/>
+    <p:sldId xmlns:r="http://schemas.openxmlformats.org/officeDocument/2006/relationships" id="258" r:id="R01833e9f0c0b4e2a"/>
+    <p:sldId xmlns:r="http://schemas.openxmlformats.org/officeDocument/2006/relationships" id="259" r:id="R961a005f49b84a9d"/>
+    <p:sldId xmlns:r="http://schemas.openxmlformats.org/officeDocument/2006/relationships" id="260" r:id="R09978b79828745cc"/>
+    <p:sldId xmlns:r="http://schemas.openxmlformats.org/officeDocument/2006/relationships" id="261" r:id="Rd6ea1b5b11cb4359"/>
+    <p:sldId xmlns:r="http://schemas.openxmlformats.org/officeDocument/2006/relationships" id="262" r:id="R21dc99ee66c6449f"/>
+    <p:sldId xmlns:r="http://schemas.openxmlformats.org/officeDocument/2006/relationships" id="263" r:id="R21387c83915648ab"/>
+    <p:sldId xmlns:r="http://schemas.openxmlformats.org/officeDocument/2006/relationships" id="264" r:id="Re1cf11c881314ce4"/>
+    <p:sldId xmlns:r="http://schemas.openxmlformats.org/officeDocument/2006/relationships" id="265" r:id="Raabf50a40c4c4cc3"/>
+    <p:sldId xmlns:r="http://schemas.openxmlformats.org/officeDocument/2006/relationships" id="266" r:id="R9422bb5aa8ef447d"/>
+    <p:sldId xmlns:r="http://schemas.openxmlformats.org/officeDocument/2006/relationships" id="267" r:id="R7491ca21505f43a8"/>
+    <p:sldId xmlns:r="http://schemas.openxmlformats.org/officeDocument/2006/relationships" id="268" r:id="Ra14fc8d257874bd9"/>
+    <p:sldId xmlns:r="http://schemas.openxmlformats.org/officeDocument/2006/relationships" id="269" r:id="R1100f3a7235b4c2b"/>
+    <p:sldId xmlns:r="http://schemas.openxmlformats.org/officeDocument/2006/relationships" id="270" r:id="Rd6780658080f4ce6"/>
   </p:sldIdLst>
   <p:sldSz cx="12192000" cy="6858000"/>
   <p:notesSz cx="6858000" cy="9144000"/>
@@ -461,17 +461,12 @@
           </a:p>
           <a:p xmlns:a="http://schemas.openxmlformats.org/drawingml/2006/main">
             <a:r>
-              <a:t>- Пользовательский вводный блок</a:t>
-            </a:r>
-          </a:p>
-          <a:p xmlns:a="http://schemas.openxmlformats.org/drawingml/2006/main">
-            <a:r>
               <a:t>- README.md</a:t>
             </a:r>
           </a:p>
           <a:p xmlns:a="http://schemas.openxmlformats.org/drawingml/2006/main">
             <a:r>
-              <a:t>- ai/ROADMAP.md</a:t>
+              <a:t>- docs/harness/README.md</a:t>
             </a:r>
           </a:p>
         </p:txBody>
@@ -546,17 +541,12 @@
           </a:p>
           <a:p xmlns:a="http://schemas.openxmlformats.org/drawingml/2006/main">
             <a:r>
-              <a:t>- docs/agent/isolation-state-validation.md</a:t>
-            </a:r>
-          </a:p>
-          <a:p xmlns:a="http://schemas.openxmlformats.org/drawingml/2006/main">
-            <a:r>
-              <a:t>- ai/agent.json</a:t>
-            </a:r>
-          </a:p>
-          <a:p xmlns:a="http://schemas.openxmlformats.org/drawingml/2006/main">
-            <a:r>
-              <a:t>- docker/agent-runner.mjs</a:t>
+              <a:t>- package.json</a:t>
+            </a:r>
+          </a:p>
+          <a:p xmlns:a="http://schemas.openxmlformats.org/drawingml/2006/main">
+            <a:r>
+              <a:t>- ai/profiles/angular-ionic-capacitor.json</a:t>
             </a:r>
           </a:p>
         </p:txBody>
@@ -631,12 +621,12 @@
           </a:p>
           <a:p xmlns:a="http://schemas.openxmlformats.org/drawingml/2006/main">
             <a:r>
-              <a:t>- docs/agent/isolation-state-validation.md</a:t>
-            </a:r>
-          </a:p>
-          <a:p xmlns:a="http://schemas.openxmlformats.org/drawingml/2006/main">
-            <a:r>
-              <a:t>- scripts/agent/tests/*.test.mjs</a:t>
+              <a:t>- docs/harness/evaluations.md</a:t>
+            </a:r>
+          </a:p>
+          <a:p xmlns:a="http://schemas.openxmlformats.org/drawingml/2006/main">
+            <a:r>
+              <a:t>- docs/harness/visual-debugging.md</a:t>
             </a:r>
           </a:p>
         </p:txBody>
@@ -711,47 +701,7 @@
           </a:p>
           <a:p xmlns:a="http://schemas.openxmlformats.org/drawingml/2006/main">
             <a:r>
-              <a:t>- docs/agent/isolation-state-validation.md</a:t>
-            </a:r>
-          </a:p>
-          <a:p xmlns:a="http://schemas.openxmlformats.org/drawingml/2006/main">
-            <a:r>
-              <a:t>- scripts/agent/tests/api.test.mjs</a:t>
-            </a:r>
-          </a:p>
-          <a:p xmlns:a="http://schemas.openxmlformats.org/drawingml/2006/main">
-            <a:r>
-              <a:t>- scripts/agent/tests/approval.test.mjs</a:t>
-            </a:r>
-          </a:p>
-          <a:p xmlns:a="http://schemas.openxmlformats.org/drawingml/2006/main">
-            <a:r>
-              <a:t>- scripts/agent/tests/executor.test.mjs</a:t>
-            </a:r>
-          </a:p>
-          <a:p xmlns:a="http://schemas.openxmlformats.org/drawingml/2006/main">
-            <a:r>
-              <a:t>- scripts/agent/tests/policy.test.mjs</a:t>
-            </a:r>
-          </a:p>
-          <a:p xmlns:a="http://schemas.openxmlformats.org/drawingml/2006/main">
-            <a:r>
-              <a:t>- scripts/agent/tests/protocol.test.mjs</a:t>
-            </a:r>
-          </a:p>
-          <a:p xmlns:a="http://schemas.openxmlformats.org/drawingml/2006/main">
-            <a:r>
-              <a:t>- scripts/agent/tests/runtime.test.mjs</a:t>
-            </a:r>
-          </a:p>
-          <a:p xmlns:a="http://schemas.openxmlformats.org/drawingml/2006/main">
-            <a:r>
-              <a:t>- scripts/agent/tests/tools.test.mjs</a:t>
-            </a:r>
-          </a:p>
-          <a:p xmlns:a="http://schemas.openxmlformats.org/drawingml/2006/main">
-            <a:r>
-              <a:t>- scripts/agent/tests/worktree.test.mjs</a:t>
+              <a:t>- docs/harness/evaluations.md</a:t>
             </a:r>
           </a:p>
         </p:txBody>
@@ -831,7 +781,7 @@
           </a:p>
           <a:p xmlns:a="http://schemas.openxmlformats.org/drawingml/2006/main">
             <a:r>
-              <a:t>- docs/agent/executors-approvals-api.md</a:t>
+              <a:t>- docs/harness/external-projects-and-opencode.md</a:t>
             </a:r>
           </a:p>
         </p:txBody>
@@ -906,12 +856,17 @@
           </a:p>
           <a:p xmlns:a="http://schemas.openxmlformats.org/drawingml/2006/main">
             <a:r>
-              <a:t>- ai/ROADMAP.md</a:t>
-            </a:r>
-          </a:p>
-          <a:p xmlns:a="http://schemas.openxmlformats.org/drawingml/2006/main">
-            <a:r>
-              <a:t>- docs/deployment-and-hardening.md</a:t>
+              <a:t>- docs/harness/visual-debugging.md</a:t>
+            </a:r>
+          </a:p>
+          <a:p xmlns:a="http://schemas.openxmlformats.org/drawingml/2006/main">
+            <a:r>
+              <a:t>- https://developer.android.com/develop/ui/views/layout/webapps/debug-chrome-devtools</a:t>
+            </a:r>
+          </a:p>
+          <a:p xmlns:a="http://schemas.openxmlformats.org/drawingml/2006/main">
+            <a:r>
+              <a:t>- https://webkit.org/blog/13936/enabling-the-inspection-of-web-content-in-apps/</a:t>
             </a:r>
           </a:p>
         </p:txBody>
@@ -986,12 +941,12 @@
           </a:p>
           <a:p xmlns:a="http://schemas.openxmlformats.org/drawingml/2006/main">
             <a:r>
-              <a:t>- ai/ROADMAP.md</a:t>
-            </a:r>
-          </a:p>
-          <a:p xmlns:a="http://schemas.openxmlformats.org/drawingml/2006/main">
-            <a:r>
-              <a:t>- docs/security.md</a:t>
+              <a:t>- docs/getting-started.md</a:t>
+            </a:r>
+          </a:p>
+          <a:p xmlns:a="http://schemas.openxmlformats.org/drawingml/2006/main">
+            <a:r>
+              <a:t>- docs/harness/faq.md</a:t>
             </a:r>
           </a:p>
         </p:txBody>
@@ -1066,12 +1021,12 @@
           </a:p>
           <a:p xmlns:a="http://schemas.openxmlformats.org/drawingml/2006/main">
             <a:r>
-              <a:t>- Пользовательский вводный блок</a:t>
-            </a:r>
-          </a:p>
-          <a:p xmlns:a="http://schemas.openxmlformats.org/drawingml/2006/main">
-            <a:r>
-              <a:t>- ai/ROADMAP.md</a:t>
+              <a:t>- docs/harness/README.md</a:t>
+            </a:r>
+          </a:p>
+          <a:p xmlns:a="http://schemas.openxmlformats.org/drawingml/2006/main">
+            <a:r>
+              <a:t>- docs/security.md</a:t>
             </a:r>
           </a:p>
         </p:txBody>
@@ -1146,12 +1101,12 @@
           </a:p>
           <a:p xmlns:a="http://schemas.openxmlformats.org/drawingml/2006/main">
             <a:r>
-              <a:t>- Пользовательский вводный блок</a:t>
-            </a:r>
-          </a:p>
-          <a:p xmlns:a="http://schemas.openxmlformats.org/drawingml/2006/main">
-            <a:r>
-              <a:t>- docs/deployment-and-hardening.md</a:t>
+              <a:t>- docs/harness/using-with-existing-projects.md</a:t>
+            </a:r>
+          </a:p>
+          <a:p xmlns:a="http://schemas.openxmlformats.org/drawingml/2006/main">
+            <a:r>
+              <a:t>- ai/remote-model.md</a:t>
             </a:r>
           </a:p>
         </p:txBody>
@@ -1226,12 +1181,12 @@
           </a:p>
           <a:p xmlns:a="http://schemas.openxmlformats.org/drawingml/2006/main">
             <a:r>
-              <a:t>- Пользовательский вводный блок</a:t>
-            </a:r>
-          </a:p>
-          <a:p xmlns:a="http://schemas.openxmlformats.org/drawingml/2006/main">
-            <a:r>
-              <a:t>- README.md</a:t>
+              <a:t>- docs/architecture.md</a:t>
+            </a:r>
+          </a:p>
+          <a:p xmlns:a="http://schemas.openxmlformats.org/drawingml/2006/main">
+            <a:r>
+              <a:t>- docs/harness/external-projects-and-opencode.md</a:t>
             </a:r>
           </a:p>
         </p:txBody>
@@ -1306,12 +1261,12 @@
           </a:p>
           <a:p xmlns:a="http://schemas.openxmlformats.org/drawingml/2006/main">
             <a:r>
+              <a:t>- docs/harness/README.md</a:t>
+            </a:r>
+          </a:p>
+          <a:p xmlns:a="http://schemas.openxmlformats.org/drawingml/2006/main">
+            <a:r>
               <a:t>- docs/agent/README.md</a:t>
-            </a:r>
-          </a:p>
-          <a:p xmlns:a="http://schemas.openxmlformats.org/drawingml/2006/main">
-            <a:r>
-              <a:t>- docs/harness/README.md</a:t>
             </a:r>
           </a:p>
         </p:txBody>
@@ -1466,17 +1421,12 @@
           </a:p>
           <a:p xmlns:a="http://schemas.openxmlformats.org/drawingml/2006/main">
             <a:r>
-              <a:t>- scripts/agent/lib/runtime.mjs</a:t>
-            </a:r>
-          </a:p>
-          <a:p xmlns:a="http://schemas.openxmlformats.org/drawingml/2006/main">
-            <a:r>
-              <a:t>- scripts/agent/lib/tools.mjs</a:t>
-            </a:r>
-          </a:p>
-          <a:p xmlns:a="http://schemas.openxmlformats.org/drawingml/2006/main">
-            <a:r>
-              <a:t>- ai/agent.json</a:t>
+              <a:t>- docs/harness/model-protocol.md</a:t>
+            </a:r>
+          </a:p>
+          <a:p xmlns:a="http://schemas.openxmlformats.org/drawingml/2006/main">
+            <a:r>
+              <a:t>- docs/agent/worktrees-and-validation.md</a:t>
             </a:r>
           </a:p>
         </p:txBody>
@@ -1551,12 +1501,7 @@
           </a:p>
           <a:p xmlns:a="http://schemas.openxmlformats.org/drawingml/2006/main">
             <a:r>
-              <a:t>- docs/agent/isolation-state-validation.md</a:t>
-            </a:r>
-          </a:p>
-          <a:p xmlns:a="http://schemas.openxmlformats.org/drawingml/2006/main">
-            <a:r>
-              <a:t>- scripts/agent/lib/worktree.mjs</a:t>
+              <a:t>- docs/harness/external-projects-and-opencode.md</a:t>
             </a:r>
           </a:p>
         </p:txBody>
@@ -1631,22 +1576,12 @@
           </a:p>
           <a:p xmlns:a="http://schemas.openxmlformats.org/drawingml/2006/main">
             <a:r>
-              <a:t>- docs/agent/isolation-state-validation.md</a:t>
-            </a:r>
-          </a:p>
-          <a:p xmlns:a="http://schemas.openxmlformats.org/drawingml/2006/main">
-            <a:r>
-              <a:t>- scripts/agent/lib/state.mjs</a:t>
-            </a:r>
-          </a:p>
-          <a:p xmlns:a="http://schemas.openxmlformats.org/drawingml/2006/main">
-            <a:r>
-              <a:t>- scripts/agent/lib/approval.mjs</a:t>
-            </a:r>
-          </a:p>
-          <a:p xmlns:a="http://schemas.openxmlformats.org/drawingml/2006/main">
-            <a:r>
-              <a:t>- scripts/agent/lib/runtime.mjs</a:t>
+              <a:t>- docs/agent/executors-approvals-api.md</a:t>
+            </a:r>
+          </a:p>
+          <a:p xmlns:a="http://schemas.openxmlformats.org/drawingml/2006/main">
+            <a:r>
+              <a:t>- docs/security.md</a:t>
             </a:r>
           </a:p>
         </p:txBody>
@@ -1714,7 +1649,7 @@
   </p:cSld>
   <p:clrMap bg1="lt1" tx1="dk1" bg2="lt2" tx2="dk2" accent1="accent1" accent2="accent2" accent3="accent3" accent4="accent4" accent5="accent5" accent6="accent6" hlink="hlink" folHlink="folHlink"/>
   <p:sldLayoutIdLst>
-    <p:sldLayoutId xmlns:r="http://schemas.openxmlformats.org/officeDocument/2006/relationships" id="2147483649" r:id="R81ba65674f684dd6"/>
+    <p:sldLayoutId xmlns:r="http://schemas.openxmlformats.org/officeDocument/2006/relationships" id="2147483649" r:id="R760f7029cd8544fb"/>
   </p:sldLayoutIdLst>
   <p:txStyles>
     <p:titleStyle>
@@ -2298,7 +2233,7 @@
             </a:pPr>
             <a:r>
               <a:rPr sz="6000"/>
-              <a:t>Агентная среда</a:t>
+              <a:t>Harness для</a:t>
             </a:r>
           </a:p>
           <a:p xmlns:a="http://schemas.openxmlformats.org/drawingml/2006/main">
@@ -2318,7 +2253,7 @@
             </a:pPr>
             <a:r>
               <a:rPr sz="6000"/>
-              <a:t>для локальной модели</a:t>
+              <a:t>локальной модели</a:t>
             </a:r>
           </a:p>
         </p:txBody>
@@ -2368,7 +2303,7 @@
             </a:pPr>
             <a:r>
               <a:rPr sz="1800"/>
-              <a:t>Контролируемая разработка гибридных приложений</a:t>
+              <a:t>Понятная и контролируемая разработка Angular, Ionic и Capacitor</a:t>
             </a:r>
           </a:p>
           <a:p xmlns:a="http://schemas.openxmlformats.org/drawingml/2006/main">
@@ -2388,7 +2323,7 @@
             </a:pPr>
             <a:r>
               <a:rPr sz="1800"/>
-              <a:t>без передачи кода внешним облачным моделям</a:t>
+              <a:t>на своём компьютере и в локальной сети</a:t>
             </a:r>
           </a:p>
         </p:txBody>
@@ -2441,7 +2376,7 @@
             </a:pPr>
             <a:r>
               <a:rPr sz="1800"/>
-              <a:t>ANGULAR • IONIC • CAPACITOR • ЛОКАЛЬНАЯ МОДЕЛЬ</a:t>
+              <a:t>ANGULAR • IONIC • CAPACITOR • GPT-OSS-20B</a:t>
             </a:r>
           </a:p>
         </p:txBody>
@@ -2564,14 +2499,14 @@
                 <a:ea typeface="Helvetica Neue"/>
                 <a:cs typeface="Helvetica Neue"/>
               </a:rPr>
-              <a:t>Полная проверка: шесть стадий перед завершением</a:t>
+              <a:t>Готовность подтверждают проверки, а не обещание модели</a:t>
             </a:r>
           </a:p>
         </p:txBody>
       </p:sp>
       <p:cxnSp>
         <p:nvCxnSpPr>
-          <p:cNvPr id="30" name="Google-Shape-2259-p159-4"/>
+          <p:cNvPr id="36" name="Google-Shape-2259-p159-4"/>
           <p:cNvCxnSpPr/>
           <p:nvPr/>
         </p:nvCxnSpPr>
@@ -2756,7 +2691,7 @@
                 <a:ea typeface="Helvetica Neue"/>
                 <a:cs typeface="Helvetica Neue"/>
               </a:rPr>
-              <a:t>1. Формат</a:t>
+              <a:t>Формат и типы</a:t>
             </a:r>
           </a:p>
           <a:p xmlns:a="http://schemas.openxmlformats.org/drawingml/2006/main">
@@ -2846,7 +2781,7 @@
                 <a:ea typeface="Helvetica Neue"/>
                 <a:cs typeface="Helvetica Neue"/>
               </a:rPr>
-              <a:t>2. Сборка</a:t>
+              <a:t>Angular build</a:t>
             </a:r>
           </a:p>
           <a:p xmlns:a="http://schemas.openxmlformats.org/drawingml/2006/main">
@@ -2876,7 +2811,7 @@
                 <a:ea typeface="Helvetica Neue"/>
                 <a:cs typeface="Helvetica Neue"/>
               </a:rPr>
-              <a:t>Производственная сборка Angular</a:t>
+              <a:t>Strict TypeScript</a:t>
             </a:r>
           </a:p>
         </p:txBody>
@@ -2965,7 +2900,7 @@
                 <a:ea typeface="Helvetica Neue"/>
                 <a:cs typeface="Helvetica Neue"/>
               </a:rPr>
-              <a:t>3. Unit-тесты</a:t>
+              <a:t>Поведение</a:t>
             </a:r>
           </a:p>
           <a:p xmlns:a="http://schemas.openxmlformats.org/drawingml/2006/main">
@@ -2995,7 +2930,7 @@
                 <a:ea typeface="Helvetica Neue"/>
                 <a:cs typeface="Helvetica Neue"/>
               </a:rPr>
-              <a:t>Логика приложения</a:t>
+              <a:t>Unit-тесты</a:t>
             </a:r>
           </a:p>
           <a:p xmlns:a="http://schemas.openxmlformats.org/drawingml/2006/main">
@@ -3055,7 +2990,7 @@
                 <a:ea typeface="Helvetica Neue"/>
                 <a:cs typeface="Helvetica Neue"/>
               </a:rPr>
-              <a:t>4. Capacitor</a:t>
+              <a:t>Capacitor check</a:t>
             </a:r>
           </a:p>
           <a:p xmlns:a="http://schemas.openxmlformats.org/drawingml/2006/main">
@@ -3085,7 +3020,7 @@
                 <a:ea typeface="Helvetica Neue"/>
                 <a:cs typeface="Helvetica Neue"/>
               </a:rPr>
-              <a:t>Локальная конфигурация</a:t>
+              <a:t>Platform config</a:t>
             </a:r>
           </a:p>
         </p:txBody>
@@ -3174,7 +3109,7 @@
                 <a:ea typeface="Helvetica Neue"/>
                 <a:cs typeface="Helvetica Neue"/>
               </a:rPr>
-              <a:t>5. Диагностика ИИ</a:t>
+              <a:t>Harness</a:t>
             </a:r>
           </a:p>
           <a:p xmlns:a="http://schemas.openxmlformats.org/drawingml/2006/main">
@@ -3204,7 +3139,7 @@
                 <a:ea typeface="Helvetica Neue"/>
                 <a:cs typeface="Helvetica Neue"/>
               </a:rPr>
-              <a:t>Наборы знаний и маршрутизация</a:t>
+              <a:t>Skill routing</a:t>
             </a:r>
           </a:p>
           <a:p xmlns:a="http://schemas.openxmlformats.org/drawingml/2006/main">
@@ -3264,7 +3199,7 @@
                 <a:ea typeface="Helvetica Neue"/>
                 <a:cs typeface="Helvetica Neue"/>
               </a:rPr>
-              <a:t>6. Тесты harness</a:t>
+              <a:t>Policy tests</a:t>
             </a:r>
           </a:p>
           <a:p xmlns:a="http://schemas.openxmlformats.org/drawingml/2006/main">
@@ -3294,7 +3229,7 @@
                 <a:ea typeface="Helvetica Neue"/>
                 <a:cs typeface="Helvetica Neue"/>
               </a:rPr>
-              <a:t>Защитный контур</a:t>
+              <a:t>Docker integration</a:t>
             </a:r>
           </a:p>
         </p:txBody>
@@ -3597,14 +3532,14 @@
                 <a:ea typeface="Helvetica Neue"/>
                 <a:cs typeface="Helvetica Neue"/>
               </a:rPr>
-              <a:t>Набор из 18 тестов проверяет сам harness</a:t>
+              <a:t>Качество проверяется на трёх уровнях</a:t>
             </a:r>
           </a:p>
         </p:txBody>
       </p:sp>
       <p:cxnSp>
         <p:nvCxnSpPr>
-          <p:cNvPr id="30" name="Google-Shape-2259-p159-4"/>
+          <p:cNvPr id="36" name="Google-Shape-2259-p159-4"/>
           <p:cNvCxnSpPr/>
           <p:nvPr/>
         </p:nvCxnSpPr>
@@ -3789,7 +3724,7 @@
                 <a:ea typeface="Helvetica Neue"/>
                 <a:cs typeface="Helvetica Neue"/>
               </a:rPr>
-              <a:t>9 тестов</a:t>
+              <a:t>12 задач</a:t>
             </a:r>
           </a:p>
           <a:p xmlns:a="http://schemas.openxmlformats.org/drawingml/2006/main">
@@ -3819,7 +3754,7 @@
                 <a:ea typeface="Helvetica Neue"/>
                 <a:cs typeface="Helvetica Neue"/>
               </a:rPr>
-              <a:t>■■■■■■■■■</a:t>
+              <a:t>■■■■■■■■■■■■</a:t>
             </a:r>
           </a:p>
           <a:p xmlns:a="http://schemas.openxmlformats.org/drawingml/2006/main">
@@ -3879,7 +3814,7 @@
                 <a:ea typeface="Helvetica Neue"/>
                 <a:cs typeface="Helvetica Neue"/>
               </a:rPr>
-              <a:t>Управление</a:t>
+              <a:t>Ответы</a:t>
             </a:r>
           </a:p>
           <a:p xmlns:a="http://schemas.openxmlformats.org/drawingml/2006/main">
@@ -3909,7 +3844,7 @@
                 <a:ea typeface="Helvetica Neue"/>
                 <a:cs typeface="Helvetica Neue"/>
               </a:rPr>
-              <a:t>правила • протокол • цикл</a:t>
+              <a:t>факты • безопасность • источники</a:t>
             </a:r>
           </a:p>
         </p:txBody>
@@ -3998,7 +3933,7 @@
                 <a:ea typeface="Helvetica Neue"/>
                 <a:cs typeface="Helvetica Neue"/>
               </a:rPr>
-              <a:t>6 тестов</a:t>
+              <a:t>Policy tests</a:t>
             </a:r>
           </a:p>
           <a:p xmlns:a="http://schemas.openxmlformats.org/drawingml/2006/main">
@@ -4028,7 +3963,7 @@
                 <a:ea typeface="Helvetica Neue"/>
                 <a:cs typeface="Helvetica Neue"/>
               </a:rPr>
-              <a:t>■■■■■■</a:t>
+              <a:t>■■■■■■■■</a:t>
             </a:r>
           </a:p>
           <a:p xmlns:a="http://schemas.openxmlformats.org/drawingml/2006/main">
@@ -4088,7 +4023,7 @@
                 <a:ea typeface="Helvetica Neue"/>
                 <a:cs typeface="Helvetica Neue"/>
               </a:rPr>
-              <a:t>Исполнение</a:t>
+              <a:t>Контроллер</a:t>
             </a:r>
           </a:p>
           <a:p xmlns:a="http://schemas.openxmlformats.org/drawingml/2006/main">
@@ -4118,7 +4053,7 @@
                 <a:ea typeface="Helvetica Neue"/>
                 <a:cs typeface="Helvetica Neue"/>
               </a:rPr>
-              <a:t>инструменты • копия • Docker</a:t>
+              <a:t>пути • approvals • diff • Docker</a:t>
             </a:r>
           </a:p>
         </p:txBody>
@@ -4207,7 +4142,7 @@
                 <a:ea typeface="Helvetica Neue"/>
                 <a:cs typeface="Helvetica Neue"/>
               </a:rPr>
-              <a:t>3 теста</a:t>
+              <a:t>Live gates</a:t>
             </a:r>
           </a:p>
           <a:p xmlns:a="http://schemas.openxmlformats.org/drawingml/2006/main">
@@ -4237,7 +4172,7 @@
                 <a:ea typeface="Helvetica Neue"/>
                 <a:cs typeface="Helvetica Neue"/>
               </a:rPr>
-              <a:t>■■■</a:t>
+              <a:t>■■■■</a:t>
             </a:r>
           </a:p>
           <a:p xmlns:a="http://schemas.openxmlformats.org/drawingml/2006/main">
@@ -4297,7 +4232,7 @@
                 <a:ea typeface="Helvetica Neue"/>
                 <a:cs typeface="Helvetica Neue"/>
               </a:rPr>
-              <a:t>Удалённая работа</a:t>
+              <a:t>Среда</a:t>
             </a:r>
           </a:p>
           <a:p xmlns:a="http://schemas.openxmlformats.org/drawingml/2006/main">
@@ -4327,7 +4262,7 @@
                 <a:ea typeface="Helvetica Neue"/>
                 <a:cs typeface="Helvetica Neue"/>
               </a:rPr>
-              <a:t>интерфейс • одобрения</a:t>
+              <a:t>OpenCode • browser • simulator • devices</a:t>
             </a:r>
           </a:p>
         </p:txBody>
@@ -4387,7 +4322,7 @@
                 <a:ea typeface="Helvetica Neue"/>
                 <a:cs typeface="Helvetica Neue"/>
               </a:rPr>
-              <a:t>ИСПОЛНЕНИЕ</a:t>
+              <a:t>ПОЛИТИКА И ИСПОЛНЕНИЕ</a:t>
             </a:r>
           </a:p>
         </p:txBody>
@@ -4447,7 +4382,7 @@
                 <a:ea typeface="Helvetica Neue"/>
                 <a:cs typeface="Helvetica Neue"/>
               </a:rPr>
-              <a:t>УПРАВЛЕНИЕ</a:t>
+              <a:t>RETRIEVAL И ОТВЕТ</a:t>
             </a:r>
           </a:p>
         </p:txBody>
@@ -4507,7 +4442,7 @@
                 <a:ea typeface="Helvetica Neue"/>
                 <a:cs typeface="Helvetica Neue"/>
               </a:rPr>
-              <a:t>УДАЛЁННЫЙ КОНТУР</a:t>
+              <a:t>END-TO-END</a:t>
             </a:r>
           </a:p>
         </p:txBody>
@@ -4630,7 +4565,7 @@
                 <a:ea typeface="Helvetica Neue"/>
                 <a:cs typeface="Helvetica Neue"/>
               </a:rPr>
-              <a:t>18 тестов harness: 8 подсистем; Docker выполняет 16</a:t>
+              <a:t>Локальную модель и Codex сравнивают по одинаковым задачам</a:t>
             </a:r>
           </a:p>
         </p:txBody>
@@ -4685,7 +4620,7 @@
                 <a:ea typeface="Helvetica Neue"/>
                 <a:cs typeface="Helvetica Neue"/>
               </a:rPr>
-              <a:t>1–4. Доступ и исполнение</a:t>
+              <a:t>Правильность</a:t>
             </a:r>
           </a:p>
           <a:p xmlns:a="http://schemas.openxmlformats.org/drawingml/2006/main">
@@ -4715,7 +4650,62 @@
                 <a:ea typeface="Helvetica Neue"/>
                 <a:cs typeface="Helvetica Neue"/>
               </a:rPr>
-              <a:t>API — 2 • одобрения — 1</a:t>
+              <a:t>Сколько задач прошло и какие обязательные факты подтверждены.</a:t>
+            </a:r>
+          </a:p>
+        </p:txBody>
+      </p:sp>
+      <p:sp>
+        <p:nvSpPr>
+          <p:cNvPr id="4" name="Content-Placeholder-10-5">
+            <a:extLst xmlns:a="http://schemas.openxmlformats.org/drawingml/2006/main">
+              <a:ext uri="{FF2B5EF4-FFF2-40B4-BE49-F238E27FC236}">
+                <a16:creationId xmlns:a16="http://schemas.microsoft.com/office/drawing/2014/main" id="{C484B9C0-4372-416B-A67C-FD96C298308B}"/>
+              </a:ext>
+            </a:extLst>
+          </p:cNvPr>
+          <p:cNvSpPr>
+            <a:spLocks xmlns:a="http://schemas.openxmlformats.org/drawingml/2006/main" noGrp="1"/>
+          </p:cNvSpPr>
+          <p:nvPr/>
+        </p:nvSpPr>
+        <p:spPr>
+          <a:xfrm xmlns:a="http://schemas.openxmlformats.org/drawingml/2006/main">
+            <a:off x="6256592" y="2031968"/>
+            <a:ext cx="5537168" cy="1643063"/>
+          </a:xfrm>
+          <a:prstGeom xmlns:a="http://schemas.openxmlformats.org/drawingml/2006/main" prst="rect">
+            <a:avLst/>
+          </a:prstGeom>
+        </p:spPr>
+        <p:txBody>
+          <a:bodyPr xmlns:a="http://schemas.openxmlformats.org/drawingml/2006/main" lIns="91440" tIns="45720" rIns="91440" bIns="45720"/>
+          <a:lstStyle xmlns:a="http://schemas.openxmlformats.org/drawingml/2006/main"/>
+          <a:p xmlns:a="http://schemas.openxmlformats.org/drawingml/2006/main">
+            <a:pPr algn="l">
+              <a:lnSpc>
+                <a:spcPct val="110000"/>
+              </a:lnSpc>
+              <a:buNone/>
+              <a:defRPr sz="2400">
+                <a:solidFill>
+                  <a:srgbClr val="000000"/>
+                </a:solidFill>
+                <a:latin typeface="Helvetica Neue"/>
+                <a:ea typeface="Helvetica Neue"/>
+                <a:cs typeface="Helvetica Neue"/>
+              </a:defRPr>
+            </a:pPr>
+            <a:r>
+              <a:rPr sz="2400">
+                <a:solidFill>
+                  <a:srgbClr val="000000"/>
+                </a:solidFill>
+                <a:latin typeface="Helvetica Neue"/>
+                <a:ea typeface="Helvetica Neue"/>
+                <a:cs typeface="Helvetica Neue"/>
+              </a:rPr>
+              <a:t>Безопасность</a:t>
             </a:r>
           </a:p>
           <a:p xmlns:a="http://schemas.openxmlformats.org/drawingml/2006/main">
@@ -4745,36 +4735,38 @@
                 <a:ea typeface="Helvetica Neue"/>
                 <a:cs typeface="Helvetica Neue"/>
               </a:rPr>
-              <a:t>Docker-исполнитель — 1</a:t>
-            </a:r>
-          </a:p>
-        </p:txBody>
-      </p:sp>
-      <p:sp>
-        <p:nvSpPr>
-          <p:cNvPr id="4" name="Content-Placeholder-10-5">
-            <a:extLst xmlns:a="http://schemas.openxmlformats.org/drawingml/2006/main">
-              <a:ext uri="{FF2B5EF4-FFF2-40B4-BE49-F238E27FC236}">
-                <a16:creationId xmlns:a16="http://schemas.microsoft.com/office/drawing/2014/main" id="{C484B9C0-4372-416B-A67C-FD96C298308B}"/>
-              </a:ext>
-            </a:extLst>
-          </p:cNvPr>
-          <p:cNvSpPr>
-            <a:spLocks xmlns:a="http://schemas.openxmlformats.org/drawingml/2006/main" noGrp="1"/>
-          </p:cNvSpPr>
-          <p:nvPr/>
-        </p:nvSpPr>
-        <p:spPr>
-          <a:xfrm xmlns:a="http://schemas.openxmlformats.org/drawingml/2006/main">
-            <a:off x="6256592" y="2031968"/>
-            <a:ext cx="5537168" cy="1643063"/>
+              <a:t>Нет ли выдуманных API, лишних permissions и raw service markers.</a:t>
+            </a:r>
+          </a:p>
+        </p:txBody>
+      </p:sp>
+      <p:sp>
+        <p:nvSpPr>
+          <p:cNvPr id="5" name="Content-Placeholder-9-6">
+            <a:extLst xmlns:a="http://schemas.openxmlformats.org/drawingml/2006/main">
+              <a:ext uri="{FF2B5EF4-FFF2-40B4-BE49-F238E27FC236}">
+                <a16:creationId xmlns:a16="http://schemas.microsoft.com/office/drawing/2014/main" id="{BA0909F4-36AF-401F-936E-0FF30DCBF4E4}"/>
+              </a:ext>
+            </a:extLst>
+          </p:cNvPr>
+          <p:cNvSpPr>
+            <a:spLocks xmlns:a="http://schemas.openxmlformats.org/drawingml/2006/main" noGrp="1"/>
+          </p:cNvSpPr>
+          <p:nvPr/>
+        </p:nvSpPr>
+        <p:spPr>
+          <a:xfrm xmlns:a="http://schemas.openxmlformats.org/drawingml/2006/main">
+            <a:off x="393668" y="4016978"/>
+            <a:ext cx="5537168" cy="1643158"/>
           </a:xfrm>
           <a:prstGeom xmlns:a="http://schemas.openxmlformats.org/drawingml/2006/main" prst="rect">
             <a:avLst/>
           </a:prstGeom>
         </p:spPr>
         <p:txBody>
-          <a:bodyPr xmlns:a="http://schemas.openxmlformats.org/drawingml/2006/main" lIns="91440" tIns="45720" rIns="91440" bIns="45720"/>
+          <a:bodyPr xmlns:a="http://schemas.openxmlformats.org/drawingml/2006/main" lIns="0" tIns="0" rIns="0" bIns="0">
+            <a:normAutofit fontScale="100000"/>
+          </a:bodyPr>
           <a:lstStyle xmlns:a="http://schemas.openxmlformats.org/drawingml/2006/main"/>
           <a:p xmlns:a="http://schemas.openxmlformats.org/drawingml/2006/main">
             <a:pPr algn="l">
@@ -4792,15 +4784,15 @@
               </a:defRPr>
             </a:pPr>
             <a:r>
-              <a:rPr sz="2400">
-                <a:solidFill>
-                  <a:srgbClr val="000000"/>
-                </a:solidFill>
-                <a:latin typeface="Helvetica Neue"/>
-                <a:ea typeface="Helvetica Neue"/>
-                <a:cs typeface="Helvetica Neue"/>
-              </a:rPr>
-              <a:t>5–10. Правила и протокол</a:t>
+              <a:rPr>
+                <a:solidFill>
+                  <a:srgbClr val="000000"/>
+                </a:solidFill>
+                <a:latin typeface="Helvetica Neue"/>
+                <a:ea typeface="Helvetica Neue"/>
+                <a:cs typeface="Helvetica Neue"/>
+              </a:rPr>
+              <a:t>Скорость</a:t>
             </a:r>
           </a:p>
           <a:p xmlns:a="http://schemas.openxmlformats.org/drawingml/2006/main">
@@ -4830,28 +4822,28 @@
                 <a:ea typeface="Helvetica Neue"/>
                 <a:cs typeface="Helvetica Neue"/>
               </a:rPr>
-              <a:t>правила — 3 • протокол — 3</a:t>
-            </a:r>
-          </a:p>
-        </p:txBody>
-      </p:sp>
-      <p:sp>
-        <p:nvSpPr>
-          <p:cNvPr id="5" name="Content-Placeholder-9-6">
-            <a:extLst xmlns:a="http://schemas.openxmlformats.org/drawingml/2006/main">
-              <a:ext uri="{FF2B5EF4-FFF2-40B4-BE49-F238E27FC236}">
-                <a16:creationId xmlns:a16="http://schemas.microsoft.com/office/drawing/2014/main" id="{BA0909F4-36AF-401F-936E-0FF30DCBF4E4}"/>
-              </a:ext>
-            </a:extLst>
-          </p:cNvPr>
-          <p:cNvSpPr>
-            <a:spLocks xmlns:a="http://schemas.openxmlformats.org/drawingml/2006/main" noGrp="1"/>
-          </p:cNvSpPr>
-          <p:nvPr/>
-        </p:nvSpPr>
-        <p:spPr>
-          <a:xfrm xmlns:a="http://schemas.openxmlformats.org/drawingml/2006/main">
-            <a:off x="393668" y="4016978"/>
+              <a:t>Latency, число attempts, tool calls и время обязательных проверок.</a:t>
+            </a:r>
+          </a:p>
+        </p:txBody>
+      </p:sp>
+      <p:sp>
+        <p:nvSpPr>
+          <p:cNvPr id="6" name="Content-Placeholder-10-7">
+            <a:extLst xmlns:a="http://schemas.openxmlformats.org/drawingml/2006/main">
+              <a:ext uri="{FF2B5EF4-FFF2-40B4-BE49-F238E27FC236}">
+                <a16:creationId xmlns:a16="http://schemas.microsoft.com/office/drawing/2014/main" id="{6D507F18-EE5D-418A-9304-A0237728BBBD}"/>
+              </a:ext>
+            </a:extLst>
+          </p:cNvPr>
+          <p:cNvSpPr>
+            <a:spLocks xmlns:a="http://schemas.openxmlformats.org/drawingml/2006/main" noGrp="1"/>
+          </p:cNvSpPr>
+          <p:nvPr/>
+        </p:nvSpPr>
+        <p:spPr>
+          <a:xfrm xmlns:a="http://schemas.openxmlformats.org/drawingml/2006/main">
+            <a:off x="6256592" y="4016978"/>
             <a:ext cx="5537168" cy="1643158"/>
           </a:xfrm>
           <a:prstGeom xmlns:a="http://schemas.openxmlformats.org/drawingml/2006/main" prst="rect">
@@ -4887,7 +4879,7 @@
                 <a:ea typeface="Helvetica Neue"/>
                 <a:cs typeface="Helvetica Neue"/>
               </a:rPr>
-              <a:t>11–16. Цикл и инструменты</a:t>
+              <a:t>Оптимальность</a:t>
             </a:r>
           </a:p>
           <a:p xmlns:a="http://schemas.openxmlformats.org/drawingml/2006/main">
@@ -4917,94 +4909,7 @@
                 <a:ea typeface="Helvetica Neue"/>
                 <a:cs typeface="Helvetica Neue"/>
               </a:rPr>
-              <a:t>цикл — 3 • инструменты — 3</a:t>
-            </a:r>
-          </a:p>
-        </p:txBody>
-      </p:sp>
-      <p:sp>
-        <p:nvSpPr>
-          <p:cNvPr id="6" name="Content-Placeholder-10-7">
-            <a:extLst xmlns:a="http://schemas.openxmlformats.org/drawingml/2006/main">
-              <a:ext uri="{FF2B5EF4-FFF2-40B4-BE49-F238E27FC236}">
-                <a16:creationId xmlns:a16="http://schemas.microsoft.com/office/drawing/2014/main" id="{6D507F18-EE5D-418A-9304-A0237728BBBD}"/>
-              </a:ext>
-            </a:extLst>
-          </p:cNvPr>
-          <p:cNvSpPr>
-            <a:spLocks xmlns:a="http://schemas.openxmlformats.org/drawingml/2006/main" noGrp="1"/>
-          </p:cNvSpPr>
-          <p:nvPr/>
-        </p:nvSpPr>
-        <p:spPr>
-          <a:xfrm xmlns:a="http://schemas.openxmlformats.org/drawingml/2006/main">
-            <a:off x="6256592" y="4016978"/>
-            <a:ext cx="5537168" cy="1643158"/>
-          </a:xfrm>
-          <a:prstGeom xmlns:a="http://schemas.openxmlformats.org/drawingml/2006/main" prst="rect">
-            <a:avLst/>
-          </a:prstGeom>
-        </p:spPr>
-        <p:txBody>
-          <a:bodyPr xmlns:a="http://schemas.openxmlformats.org/drawingml/2006/main" lIns="0" tIns="0" rIns="0" bIns="0">
-            <a:normAutofit fontScale="100000"/>
-          </a:bodyPr>
-          <a:lstStyle xmlns:a="http://schemas.openxmlformats.org/drawingml/2006/main"/>
-          <a:p xmlns:a="http://schemas.openxmlformats.org/drawingml/2006/main">
-            <a:pPr algn="l">
-              <a:lnSpc>
-                <a:spcPct val="110000"/>
-              </a:lnSpc>
-              <a:buNone/>
-              <a:defRPr sz="2400">
-                <a:solidFill>
-                  <a:srgbClr val="000000"/>
-                </a:solidFill>
-                <a:latin typeface="Helvetica Neue"/>
-                <a:ea typeface="Helvetica Neue"/>
-                <a:cs typeface="Helvetica Neue"/>
-              </a:defRPr>
-            </a:pPr>
-            <a:r>
-              <a:rPr>
-                <a:solidFill>
-                  <a:srgbClr val="000000"/>
-                </a:solidFill>
-                <a:latin typeface="Helvetica Neue"/>
-                <a:ea typeface="Helvetica Neue"/>
-                <a:cs typeface="Helvetica Neue"/>
-              </a:rPr>
-              <a:t>17–18. Git worktree</a:t>
-            </a:r>
-          </a:p>
-          <a:p xmlns:a="http://schemas.openxmlformats.org/drawingml/2006/main">
-            <a:pPr algn="l">
-              <a:spcBef>
-                <a:spcPts val="1300"/>
-              </a:spcBef>
-              <a:spcAft>
-                <a:spcPts val="1300"/>
-              </a:spcAft>
-              <a:buNone/>
-              <a:defRPr sz="2400">
-                <a:solidFill>
-                  <a:srgbClr val="000000"/>
-                </a:solidFill>
-                <a:latin typeface="Helvetica Neue"/>
-                <a:ea typeface="Helvetica Neue"/>
-                <a:cs typeface="Helvetica Neue"/>
-              </a:defRPr>
-            </a:pPr>
-            <a:r>
-              <a:rPr sz="1800">
-                <a:solidFill>
-                  <a:srgbClr val="000000"/>
-                </a:solidFill>
-                <a:latin typeface="Helvetica Neue"/>
-                <a:ea typeface="Helvetica Neue"/>
-                <a:cs typeface="Helvetica Neue"/>
-              </a:rPr>
-              <a:t>2 теста</a:t>
+              <a:t>Короткий ответ, небольшой diff, минимум лишних файлов и стабильность повторов.</a:t>
             </a:r>
           </a:p>
         </p:txBody>
@@ -5129,7 +5034,7 @@
                 <a:ea typeface="Helvetica Neue"/>
                 <a:cs typeface="Helvetica Neue"/>
               </a:rPr>
-              <a:t>Безопасность обеспечивают независимые технические границы</a:t>
+              <a:t>Безопасность создают независимые технические границы</a:t>
             </a:r>
           </a:p>
         </p:txBody>
@@ -5243,7 +5148,7 @@
                 <a:ea typeface="Helvetica Neue"/>
                 <a:cs typeface="Helvetica Neue"/>
               </a:rPr>
-              <a:t>Разрешённые знания</a:t>
+              <a:t>Проверенные global skills</a:t>
             </a:r>
           </a:p>
         </p:txBody>
@@ -5427,7 +5332,7 @@
                 <a:ea typeface="Helvetica Neue"/>
                 <a:cs typeface="Helvetica Neue"/>
               </a:rPr>
-              <a:t>Docker работает без сети, с ограничением памяти, процессора и числа процессов.</a:t>
+              <a:t>Docker работает без сети и с лимитами ресурсов. Connection details, secrets и state остаются вне проекта.</a:t>
             </a:r>
           </a:p>
           <a:p xmlns:a="http://schemas.openxmlformats.org/drawingml/2006/main">
@@ -5487,7 +5392,7 @@
                 <a:ea typeface="Helvetica Neue"/>
                 <a:cs typeface="Helvetica Neue"/>
               </a:rPr>
-              <a:t>Защищённые изменения требуют одобрения точного набора изменений; секреты закрыты всегда.</a:t>
+              <a:t>Ни prompt, ни skill не могут расширить полномочия controller.</a:t>
             </a:r>
           </a:p>
         </p:txBody>
@@ -5544,7 +5449,7 @@
                 <a:ea typeface="Helvetica Neue"/>
                 <a:cs typeface="Helvetica Neue"/>
               </a:rPr>
-              <a:t>Структурированные инструменты</a:t>
+              <a:t>Структурированные MCP tools</a:t>
             </a:r>
           </a:p>
         </p:txBody>
@@ -5725,7 +5630,7 @@
                 <a:ea typeface="Helvetica Neue"/>
                 <a:cs typeface="Helvetica Neue"/>
               </a:rPr>
-              <a:t>Правила путей и изменений</a:t>
+              <a:t>Правила путей и patch</a:t>
             </a:r>
           </a:p>
         </p:txBody>
@@ -5906,7 +5811,7 @@
                 <a:ea typeface="Helvetica Neue"/>
                 <a:cs typeface="Helvetica Neue"/>
               </a:rPr>
-              <a:t>Одноразовая рабочая копия</a:t>
+              <a:t>Внешний Git worktree</a:t>
             </a:r>
           </a:p>
         </p:txBody>
@@ -6087,7 +5992,7 @@
                 <a:ea typeface="Helvetica Neue"/>
                 <a:cs typeface="Helvetica Neue"/>
               </a:rPr>
-              <a:t>Обязательные проверки</a:t>
+              <a:t>Сборка, тесты и review</a:t>
             </a:r>
           </a:p>
         </p:txBody>
@@ -6334,14 +6239,14 @@
                 <a:ea typeface="Helvetica Neue"/>
                 <a:cs typeface="Helvetica Neue"/>
               </a:rPr>
-              <a:t>Следующий рубеж — управляемый удалённый сервис</a:t>
+              <a:t>Visual QA видит web, Android и iOS разными безопасными каналами</a:t>
             </a:r>
           </a:p>
         </p:txBody>
       </p:sp>
       <p:cxnSp>
         <p:nvCxnSpPr>
-          <p:cNvPr id="27" name="Google-Shape-2259-p159-4"/>
+          <p:cNvPr id="33" name="Google-Shape-2259-p159-4"/>
           <p:cNvCxnSpPr/>
           <p:nvPr/>
         </p:nvCxnSpPr>
@@ -6494,7 +6399,7 @@
                 <a:ea typeface="Helvetica Neue"/>
                 <a:cs typeface="Helvetica Neue"/>
               </a:rPr>
-              <a:t>СЕЙЧАС</a:t>
+              <a:t>WEB</a:t>
             </a:r>
           </a:p>
         </p:txBody>
@@ -6551,7 +6456,7 @@
                 <a:ea typeface="Helvetica Neue"/>
                 <a:cs typeface="Helvetica Neue"/>
               </a:rPr>
-              <a:t>СЛЕДОМ</a:t>
+              <a:t>ANDROID</a:t>
             </a:r>
           </a:p>
         </p:txBody>
@@ -6608,7 +6513,7 @@
                 <a:ea typeface="Helvetica Neue"/>
                 <a:cs typeface="Helvetica Neue"/>
               </a:rPr>
-              <a:t>ЗАТЕМ</a:t>
+              <a:t>iOS</a:t>
             </a:r>
           </a:p>
         </p:txBody>
@@ -6668,7 +6573,7 @@
                 <a:ea typeface="Helvetica Neue"/>
                 <a:cs typeface="Helvetica Neue"/>
               </a:rPr>
-              <a:t>Надёжная координация</a:t>
+              <a:t>WebView</a:t>
             </a:r>
           </a:p>
           <a:p xmlns:a="http://schemas.openxmlformats.org/drawingml/2006/main">
@@ -6698,7 +6603,7 @@
                 <a:ea typeface="Helvetica Neue"/>
                 <a:cs typeface="Helvetica Neue"/>
               </a:rPr>
-              <a:t>SQLite, транзакционная блокировка, очередь, одноразовые решения и очистка.</a:t>
+              <a:t>Точный ADB target даёт bounded DOM и screenshot без произвольного shell.</a:t>
             </a:r>
           </a:p>
         </p:txBody>
@@ -6758,7 +6663,7 @@
                 <a:ea typeface="Helvetica Neue"/>
                 <a:cs typeface="Helvetica Neue"/>
               </a:rPr>
-              <a:t>Безопасная основа</a:t>
+              <a:t>Полный анализ</a:t>
             </a:r>
           </a:p>
           <a:p xmlns:a="http://schemas.openxmlformats.org/drawingml/2006/main">
@@ -6788,7 +6693,7 @@
                 <a:ea typeface="Helvetica Neue"/>
                 <a:cs typeface="Helvetica Neue"/>
               </a:rPr>
-              <a:t>Docker без сети, сохраняемое состояние, точечные одобрения и локальный интерфейс.</a:t>
+              <a:t>Playwright измеряет DOM, делает screenshot и сравнивает его с PNG-макетом.</a:t>
             </a:r>
           </a:p>
         </p:txBody>
@@ -6848,7 +6753,7 @@
                 <a:ea typeface="Helvetica Neue"/>
                 <a:cs typeface="Helvetica Neue"/>
               </a:rPr>
-              <a:t>Удалённое использование</a:t>
+              <a:t>Simulator и device</a:t>
             </a:r>
           </a:p>
           <a:p xmlns:a="http://schemas.openxmlformats.org/drawingml/2006/main">
@@ -6878,7 +6783,7 @@
                 <a:ea typeface="Helvetica Neue"/>
                 <a:cs typeface="Helvetica Neue"/>
               </a:rPr>
-              <a:t>Шифрованный шлюз, подтверждённая личность, происхождение результата и наблюдаемость.</a:t>
+              <a:t>simctl даёт screenshot; DOM physical device подключается через готовую Appium session.</a:t>
             </a:r>
           </a:p>
         </p:txBody>
@@ -6950,7 +6855,7 @@
             </a:pPr>
             <a:r>
               <a:rPr sz="6000"/>
-              <a:t>Код остаётся под контролем.</a:t>
+              <a:t>Начните с одной</a:t>
             </a:r>
           </a:p>
           <a:p xmlns:a="http://schemas.openxmlformats.org/drawingml/2006/main">
@@ -6970,7 +6875,7 @@
             </a:pPr>
             <a:r>
               <a:rPr sz="6000"/>
-              <a:t>Модель ускоряет работу.</a:t>
+              <a:t>безопасной задачи.</a:t>
             </a:r>
           </a:p>
         </p:txBody>
@@ -7023,7 +6928,7 @@
             </a:pPr>
             <a:r>
               <a:rPr sz="2000"/>
-              <a:t>Знания — ограничены</a:t>
+              <a:t>1. doctor и smoke</a:t>
             </a:r>
           </a:p>
           <a:p xmlns:a="http://schemas.openxmlformats.org/drawingml/2006/main">
@@ -7046,7 +6951,7 @@
             </a:pPr>
             <a:r>
               <a:rPr sz="2000"/>
-              <a:t>Действия — разрешены</a:t>
+              <a:t>2. OpenCode в worktree</a:t>
             </a:r>
           </a:p>
           <a:p xmlns:a="http://schemas.openxmlformats.org/drawingml/2006/main">
@@ -7069,7 +6974,7 @@
             </a:pPr>
             <a:r>
               <a:rPr sz="2000"/>
-              <a:t>Результат — проверен</a:t>
+              <a:t>3. review HTML и patch</a:t>
             </a:r>
           </a:p>
         </p:txBody>
@@ -7122,7 +7027,7 @@
             </a:pPr>
             <a:r>
               <a:rPr sz="1800"/>
-              <a:t>ЦЕЛЕВОЙ РЕЗУЛЬТАТ</a:t>
+              <a:t>ПРАКТИЧЕСКИЙ СТАРТ</a:t>
             </a:r>
           </a:p>
         </p:txBody>
@@ -7245,7 +7150,7 @@
                 <a:ea typeface="Helvetica Neue"/>
                 <a:cs typeface="Helvetica Neue"/>
               </a:rPr>
-              <a:t>Зачем проекту локальная агентная среда</a:t>
+              <a:t>Зачем нужен harness</a:t>
             </a:r>
           </a:p>
         </p:txBody>
@@ -7300,7 +7205,7 @@
                 <a:ea typeface="Helvetica Neue"/>
                 <a:cs typeface="Helvetica Neue"/>
               </a:rPr>
-              <a:t>1. Сохранить конфиденциальность</a:t>
+              <a:t>1. Сохранить код внутри</a:t>
             </a:r>
           </a:p>
           <a:p xmlns:a="http://schemas.openxmlformats.org/drawingml/2006/main">
@@ -7330,7 +7235,7 @@
                 <a:ea typeface="Helvetica Neue"/>
                 <a:cs typeface="Helvetica Neue"/>
               </a:rPr>
-              <a:t>Код и внутренние данные остаются в контролируемом контуре.</a:t>
+              <a:t>Проект и внутренние данные остаются в контролируемом контуре.</a:t>
             </a:r>
           </a:p>
         </p:txBody>
@@ -7385,7 +7290,7 @@
                 <a:ea typeface="Helvetica Neue"/>
                 <a:cs typeface="Helvetica Neue"/>
               </a:rPr>
-              <a:t>2. Ограничить знания</a:t>
+              <a:t>2. Дать нужные знания</a:t>
             </a:r>
           </a:p>
           <a:p xmlns:a="http://schemas.openxmlformats.org/drawingml/2006/main">
@@ -7415,7 +7320,7 @@
                 <a:ea typeface="Helvetica Neue"/>
                 <a:cs typeface="Helvetica Neue"/>
               </a:rPr>
-              <a:t>Модель получает только сведения об используемом технологическом стеке.</a:t>
+              <a:t>Skills подбираются под конкретную задачу, а не загружаются все сразу.</a:t>
             </a:r>
           </a:p>
         </p:txBody>
@@ -7472,7 +7377,7 @@
                 <a:ea typeface="Helvetica Neue"/>
                 <a:cs typeface="Helvetica Neue"/>
               </a:rPr>
-              <a:t>3. Управлять действиями</a:t>
+              <a:t>3. Ограничить действия</a:t>
             </a:r>
           </a:p>
           <a:p xmlns:a="http://schemas.openxmlformats.org/drawingml/2006/main">
@@ -7502,7 +7407,7 @@
                 <a:ea typeface="Helvetica Neue"/>
                 <a:cs typeface="Helvetica Neue"/>
               </a:rPr>
-              <a:t>Открытые решения связывают модель с разрешёнными инструментами и проверками.</a:t>
+              <a:t>Файлы, патчи и проверки проходят через фиксированные инструменты.</a:t>
             </a:r>
           </a:p>
         </p:txBody>
@@ -7589,7 +7494,7 @@
                 <a:ea typeface="Helvetica Neue"/>
                 <a:cs typeface="Helvetica Neue"/>
               </a:rPr>
-              <a:t>Модель ускоряет разработку, но не получает неограниченный доступ к системе.</a:t>
+              <a:t>ИИ помогает быстрее, но не получает свободный доступ к компьютеру.</a:t>
             </a:r>
           </a:p>
         </p:txBody>
@@ -7712,14 +7617,14 @@
                 <a:ea typeface="Helvetica Neue"/>
                 <a:cs typeface="Helvetica Neue"/>
               </a:rPr>
-              <a:t>Три шага к рабочей среде</a:t>
+              <a:t>Три шага до первой задачи</a:t>
             </a:r>
           </a:p>
         </p:txBody>
       </p:sp>
       <p:cxnSp>
         <p:nvCxnSpPr>
-          <p:cNvPr id="27" name="Google-Shape-2259-p159-4"/>
+          <p:cNvPr id="33" name="Google-Shape-2259-p159-4"/>
           <p:cNvCxnSpPr/>
           <p:nvPr/>
         </p:nvCxnSpPr>
@@ -8046,7 +7951,7 @@
                 <a:ea typeface="Helvetica Neue"/>
                 <a:cs typeface="Helvetica Neue"/>
               </a:rPr>
-              <a:t>Защитить соединение</a:t>
+              <a:t>Подключить модель</a:t>
             </a:r>
           </a:p>
           <a:p xmlns:a="http://schemas.openxmlformats.org/drawingml/2006/main">
@@ -8076,7 +7981,7 @@
                 <a:ea typeface="Helvetica Neue"/>
                 <a:cs typeface="Helvetica Neue"/>
               </a:rPr>
-              <a:t>Локальная сеть, шифрование и проверка личности ограничивают доступ к серверу.</a:t>
+              <a:t>LM Studio предоставляет OpenAI-compatible API в доверенной локальной сети.</a:t>
             </a:r>
           </a:p>
         </p:txBody>
@@ -8136,7 +8041,7 @@
                 <a:ea typeface="Helvetica Neue"/>
                 <a:cs typeface="Helvetica Neue"/>
               </a:rPr>
-              <a:t>Развернуть модель</a:t>
+              <a:t>Установить harness</a:t>
             </a:r>
           </a:p>
           <a:p xmlns:a="http://schemas.openxmlformats.org/drawingml/2006/main">
@@ -8166,7 +8071,7 @@
                 <a:ea typeface="Helvetica Neue"/>
                 <a:cs typeface="Helvetica Neue"/>
               </a:rPr>
-              <a:t>LM Studio или Ollama запускает выбранную генеративную модель на выделенной системе.</a:t>
+              <a:t>Один общий каталог, Docker-образ и global skills обслуживают разные проекты.</a:t>
             </a:r>
           </a:p>
         </p:txBody>
@@ -8226,7 +8131,7 @@
                 <a:ea typeface="Helvetica Neue"/>
                 <a:cs typeface="Helvetica Neue"/>
               </a:rPr>
-              <a:t>Подключить разработчика</a:t>
+              <a:t>Запустить задачу</a:t>
             </a:r>
           </a:p>
           <a:p xmlns:a="http://schemas.openxmlformats.org/drawingml/2006/main">
@@ -8256,7 +8161,7 @@
                 <a:ea typeface="Helvetica Neue"/>
                 <a:cs typeface="Helvetica Neue"/>
               </a:rPr>
-              <a:t>OpenCode, Docker и VS Code образуют управляемое рабочее место.</a:t>
+              <a:t>OpenCode получает только разрешённые tools, а результат остаётся на review.</a:t>
             </a:r>
           </a:p>
         </p:txBody>
@@ -8379,7 +8284,7 @@
                 <a:ea typeface="Helvetica Neue"/>
                 <a:cs typeface="Helvetica Neue"/>
               </a:rPr>
-              <a:t>Каждая программа решает отдельную задачу</a:t>
+              <a:t>Каждый компонент делает только свою работу</a:t>
             </a:r>
           </a:p>
         </p:txBody>
@@ -8434,7 +8339,7 @@
                 <a:ea typeface="Helvetica Neue"/>
                 <a:cs typeface="Helvetica Neue"/>
               </a:rPr>
-              <a:t>LM Studio или Ollama</a:t>
+              <a:t>LM Studio</a:t>
             </a:r>
           </a:p>
           <a:p xmlns:a="http://schemas.openxmlformats.org/drawingml/2006/main">
@@ -8464,7 +8369,7 @@
                 <a:ea typeface="Helvetica Neue"/>
                 <a:cs typeface="Helvetica Neue"/>
               </a:rPr>
-              <a:t>Запускает локальную модель и предоставляет совместимую точку доступа.</a:t>
+              <a:t>Запускает gpt-oss-20b и публикует совместимую точку API.</a:t>
             </a:r>
           </a:p>
         </p:txBody>
@@ -8549,7 +8454,7 @@
                 <a:ea typeface="Helvetica Neue"/>
                 <a:cs typeface="Helvetica Neue"/>
               </a:rPr>
-              <a:t>Ведёт диалог с моделью и передаёт ей только разрешённые действия.</a:t>
+              <a:t>Ведёт диалог, выбирает skills и вызывает инструменты harness.</a:t>
             </a:r>
           </a:p>
         </p:txBody>
@@ -8606,7 +8511,7 @@
                 <a:ea typeface="Helvetica Neue"/>
                 <a:cs typeface="Helvetica Neue"/>
               </a:rPr>
-              <a:t>Docker</a:t>
+              <a:t>Harness + Docker</a:t>
             </a:r>
           </a:p>
           <a:p xmlns:a="http://schemas.openxmlformats.org/drawingml/2006/main">
@@ -8636,7 +8541,7 @@
                 <a:ea typeface="Helvetica Neue"/>
                 <a:cs typeface="Helvetica Neue"/>
               </a:rPr>
-              <a:t>Изолирует применение изменений и проверки без доступа к сети.</a:t>
+              <a:t>Ограничивают доступ, изолируют изменения и запускают проверки.</a:t>
             </a:r>
           </a:p>
         </p:txBody>
@@ -8693,7 +8598,7 @@
                 <a:ea typeface="Helvetica Neue"/>
                 <a:cs typeface="Helvetica Neue"/>
               </a:rPr>
-              <a:t>VS Code</a:t>
+              <a:t>Разработчик</a:t>
             </a:r>
           </a:p>
           <a:p xmlns:a="http://schemas.openxmlformats.org/drawingml/2006/main">
@@ -8723,7 +8628,7 @@
                 <a:ea typeface="Helvetica Neue"/>
                 <a:cs typeface="Helvetica Neue"/>
               </a:rPr>
-              <a:t>Остаётся основной средой разработки, ревью и принятия результата человеком.</a:t>
+              <a:t>Формулирует задачу, одобряет чувствительные изменения и принимает patch.</a:t>
             </a:r>
           </a:p>
         </p:txBody>
@@ -8848,7 +8753,7 @@
                 <a:ea typeface="Helvetica Neue"/>
                 <a:cs typeface="Helvetica Neue"/>
               </a:rPr>
-              <a:t>Модель становится агентом только внутри управляемой среды</a:t>
+              <a:t>Модель становится ассистентом только внутри harness</a:t>
             </a:r>
           </a:p>
         </p:txBody>
@@ -8905,7 +8810,7 @@
                 <a:ea typeface="Helvetica Neue"/>
                 <a:cs typeface="Helvetica Neue"/>
               </a:rPr>
-              <a:t>Большая языковая модель</a:t>
+              <a:t>Языковая модель</a:t>
             </a:r>
           </a:p>
           <a:p xmlns:a="http://schemas.openxmlformats.org/drawingml/2006/main">
@@ -8932,7 +8837,7 @@
                 <a:ea typeface="Helvetica Neue"/>
                 <a:cs typeface="Helvetica Neue"/>
               </a:rPr>
-              <a:t>Создаёт текст и код по переданному контексту.</a:t>
+              <a:t>Предлагает текст, код и следующий шаг.</a:t>
             </a:r>
           </a:p>
           <a:p xmlns:a="http://schemas.openxmlformats.org/drawingml/2006/main">
@@ -8986,7 +8891,7 @@
                 <a:ea typeface="Helvetica Neue"/>
                 <a:cs typeface="Helvetica Neue"/>
               </a:rPr>
-              <a:t>Сама не видит файлы, не запускает проверки и может ошибаться.</a:t>
+              <a:t>Может ошибаться и не имеет собственных прав на файлы или команды.</a:t>
             </a:r>
           </a:p>
         </p:txBody>
@@ -9046,7 +8951,7 @@
                 <a:ea typeface="Helvetica Neue"/>
                 <a:cs typeface="Helvetica Neue"/>
               </a:rPr>
-              <a:t>Агентная среда</a:t>
+              <a:t>Harness</a:t>
             </a:r>
           </a:p>
           <a:p xmlns:a="http://schemas.openxmlformats.org/drawingml/2006/main">
@@ -9073,7 +8978,7 @@
                 <a:ea typeface="Helvetica Neue"/>
                 <a:cs typeface="Helvetica Neue"/>
               </a:rPr>
-              <a:t>Подбирает знания, формирует запрос, ограничивает инструменты, изолирует изменения и требует доказательства готовности.</a:t>
+              <a:t>Решает, что модель увидит, какие tools доступны, где появится patch и какие доказательства обязательны.</a:t>
             </a:r>
           </a:p>
         </p:txBody>
@@ -9196,7 +9101,7 @@
                 <a:ea typeface="Helvetica Neue"/>
                 <a:cs typeface="Helvetica Neue"/>
               </a:rPr>
-              <a:t>Четыре слоя разделяют знания, действия и доказательства</a:t>
+              <a:t>Четыре границы делают работу управляемой</a:t>
             </a:r>
           </a:p>
         </p:txBody>
@@ -9251,7 +9156,7 @@
                 <a:ea typeface="Helvetica Neue"/>
                 <a:cs typeface="Helvetica Neue"/>
               </a:rPr>
-              <a:t>1. Репозиторий</a:t>
+              <a:t>1. Проект</a:t>
             </a:r>
           </a:p>
           <a:p xmlns:a="http://schemas.openxmlformats.org/drawingml/2006/main">
@@ -9281,7 +9186,7 @@
                 <a:ea typeface="Helvetica Neue"/>
                 <a:cs typeface="Helvetica Neue"/>
               </a:rPr>
-              <a:t>Angular 22, Ionic и Capacitor — код читается только по запросу.</a:t>
+              <a:t>Код читается порциями и только через policy; secrets всегда закрыты.</a:t>
             </a:r>
           </a:p>
         </p:txBody>
@@ -9366,7 +9271,7 @@
                 <a:ea typeface="Helvetica Neue"/>
                 <a:cs typeface="Helvetica Neue"/>
               </a:rPr>
-              <a:t>Два разрешённых набора навыков выбираются по содержанию задачи.</a:t>
+              <a:t>Global skills выбираются динамически из проверенного allowlist.</a:t>
             </a:r>
           </a:p>
         </p:txBody>
@@ -9423,7 +9328,7 @@
                 <a:ea typeface="Helvetica Neue"/>
                 <a:cs typeface="Helvetica Neue"/>
               </a:rPr>
-              <a:t>3. Управление</a:t>
+              <a:t>3. Действия</a:t>
             </a:r>
           </a:p>
           <a:p xmlns:a="http://schemas.openxmlformats.org/drawingml/2006/main">
@@ -9453,7 +9358,7 @@
                 <a:ea typeface="Helvetica Neue"/>
                 <a:cs typeface="Helvetica Neue"/>
               </a:rPr>
-              <a:t>Правила путей, лимиты, точечные одобрения и исполнитель Docker.</a:t>
+              <a:t>Нет произвольного shell: доступны чтение, patch и versioned checks.</a:t>
             </a:r>
           </a:p>
         </p:txBody>
@@ -9510,7 +9415,7 @@
                 <a:ea typeface="Helvetica Neue"/>
                 <a:cs typeface="Helvetica Neue"/>
               </a:rPr>
-              <a:t>4. Доказательство</a:t>
+              <a:t>4. Доказательства</a:t>
             </a:r>
           </a:p>
           <a:p xmlns:a="http://schemas.openxmlformats.org/drawingml/2006/main">
@@ -9540,7 +9445,7 @@
                 <a:ea typeface="Helvetica Neue"/>
                 <a:cs typeface="Helvetica Neue"/>
               </a:rPr>
-              <a:t>Обособленная копия Git, шесть проверок и хеш результата.</a:t>
+              <a:t>Отдельный Git worktree, результаты тестов и sealed hash patch.</a:t>
             </a:r>
           </a:p>
         </p:txBody>
@@ -9663,14 +9568,14 @@
                 <a:ea typeface="Helvetica Neue"/>
                 <a:cs typeface="Helvetica Neue"/>
               </a:rPr>
-              <a:t>Цикл агента: исследовать → изменить → доказать</a:t>
+              <a:t>Рабочий цикл: понять → изменить → доказать</a:t>
             </a:r>
           </a:p>
         </p:txBody>
       </p:sp>
       <p:cxnSp>
         <p:nvCxnSpPr>
-          <p:cNvPr id="30" name="Google-Shape-2259-p159-4"/>
+          <p:cNvPr id="36" name="Google-Shape-2259-p159-4"/>
           <p:cNvCxnSpPr/>
           <p:nvPr/>
         </p:nvCxnSpPr>
@@ -9855,7 +9760,7 @@
                 <a:ea typeface="Helvetica Neue"/>
                 <a:cs typeface="Helvetica Neue"/>
               </a:rPr>
-              <a:t>Исследовать</a:t>
+              <a:t>Понять</a:t>
             </a:r>
           </a:p>
           <a:p xmlns:a="http://schemas.openxmlformats.org/drawingml/2006/main">
@@ -9885,7 +9790,7 @@
                 <a:ea typeface="Helvetica Neue"/>
                 <a:cs typeface="Helvetica Neue"/>
               </a:rPr>
-              <a:t>Список файлов, поиск и ограниченное чтение разрешённой части репозитория.</a:t>
+              <a:t>Модель читает только релевантные skills и разрешённые части проекта.</a:t>
             </a:r>
           </a:p>
         </p:txBody>
@@ -10004,7 +9909,7 @@
                 <a:ea typeface="Helvetica Neue"/>
                 <a:cs typeface="Helvetica Neue"/>
               </a:rPr>
-              <a:t>Только единый набор изменений Git; правила проверяют путь, тип и размер.</a:t>
+              <a:t>Готовит стандартный Git diff в отдельной рабочей копии.</a:t>
             </a:r>
           </a:p>
         </p:txBody>
@@ -10123,7 +10028,7 @@
                 <a:ea typeface="Helvetica Neue"/>
                 <a:cs typeface="Helvetica Neue"/>
               </a:rPr>
-              <a:t>Шесть обязательных стадий; ошибка возвращает задачу на исправление.</a:t>
+              <a:t>Сборка и тесты либо подтверждают patch, либо возвращают ошибку на исправление.</a:t>
             </a:r>
           </a:p>
         </p:txBody>
@@ -10303,7 +10208,7 @@
                 <a:ea typeface="Helvetica Neue"/>
                 <a:cs typeface="Helvetica Neue"/>
               </a:rPr>
-              <a:t>ПРОВЕРКА</a:t>
+              <a:t>ДОКАЗАТЕЛЬСТВО</a:t>
             </a:r>
           </a:p>
         </p:txBody>
@@ -10426,14 +10331,14 @@
                 <a:ea typeface="Helvetica Neue"/>
                 <a:cs typeface="Helvetica Neue"/>
               </a:rPr>
-              <a:t>Git worktree отделяет изменения каждого запуска</a:t>
+              <a:t>Основной проект остаётся чистым до решения человека</a:t>
             </a:r>
           </a:p>
         </p:txBody>
       </p:sp>
       <p:cxnSp>
         <p:nvCxnSpPr>
-          <p:cNvPr id="27" name="Google-Shape-2259-p159-4"/>
+          <p:cNvPr id="33" name="Google-Shape-2259-p159-4"/>
           <p:cNvCxnSpPr/>
           <p:nvPr/>
         </p:nvCxnSpPr>
@@ -10760,7 +10665,7 @@
                 <a:ea typeface="Helvetica Neue"/>
                 <a:cs typeface="Helvetica Neue"/>
               </a:rPr>
-              <a:t>Обособленная копия</a:t>
+              <a:t>Внешний worktree</a:t>
             </a:r>
           </a:p>
           <a:p xmlns:a="http://schemas.openxmlformats.org/drawingml/2006/main">
@@ -10790,7 +10695,7 @@
                 <a:ea typeface="Helvetica Neue"/>
                 <a:cs typeface="Helvetica Neue"/>
               </a:rPr>
-              <a:t>Каталог .agent/worktrees/&lt;run-id&gt; создаётся от текущего коммита без привязки к ветке.</a:t>
+              <a:t>Все чтения, патчи и проверки происходят вне primary checkout.</a:t>
             </a:r>
           </a:p>
         </p:txBody>
@@ -10850,7 +10755,7 @@
                 <a:ea typeface="Helvetica Neue"/>
                 <a:cs typeface="Helvetica Neue"/>
               </a:rPr>
-              <a:t>Зафиксированное состояние</a:t>
+              <a:t>Чистый HEAD</a:t>
             </a:r>
           </a:p>
           <a:p xmlns:a="http://schemas.openxmlformats.org/drawingml/2006/main">
@@ -10880,7 +10785,7 @@
                 <a:ea typeface="Helvetica Neue"/>
                 <a:cs typeface="Helvetica Neue"/>
               </a:rPr>
-              <a:t>Контроллер запрещает запуск, если в основной копии есть незакоммиченные файлы.</a:t>
+              <a:t>Run начинается только от зафиксированного коммита без чужих незавершённых изменений.</a:t>
             </a:r>
           </a:p>
         </p:txBody>
@@ -10940,7 +10845,7 @@
                 <a:ea typeface="Helvetica Neue"/>
                 <a:cs typeface="Helvetica Neue"/>
               </a:rPr>
-              <a:t>Проверка или применение</a:t>
+              <a:t>Review и apply</a:t>
             </a:r>
           </a:p>
           <a:p xmlns:a="http://schemas.openxmlformats.org/drawingml/2006/main">
@@ -10970,7 +10875,7 @@
                 <a:ea typeface="Helvetica Neue"/>
                 <a:cs typeface="Helvetica Neue"/>
               </a:rPr>
-              <a:t>Патч остаётся для человека либо переносится явным флагом --apply.</a:t>
+              <a:t>Harness запечатывает patch; перенос в проект выполняет только человек.</a:t>
             </a:r>
           </a:p>
         </p:txBody>
@@ -11095,7 +11000,7 @@
                 <a:ea typeface="Helvetica Neue"/>
                 <a:cs typeface="Helvetica Neue"/>
               </a:rPr>
-              <a:t>Состояние сохраняет задачу, одобрение ограничивает действие</a:t>
+              <a:t>Чувствительное изменение не проходит незаметно</a:t>
             </a:r>
           </a:p>
         </p:txBody>
@@ -11152,7 +11057,7 @@
                 <a:ea typeface="Helvetica Neue"/>
                 <a:cs typeface="Helvetica Neue"/>
               </a:rPr>
-              <a:t>Сохраняемое состояние</a:t>
+              <a:t>Обычный patch</a:t>
             </a:r>
           </a:p>
           <a:p xmlns:a="http://schemas.openxmlformats.org/drawingml/2006/main">
@@ -11179,7 +11084,7 @@
                 <a:ea typeface="Helvetica Neue"/>
                 <a:cs typeface="Helvetica Neue"/>
               </a:rPr>
-              <a:t>state.json хранит историю, счётчики, следующую итерацию и ожидающий запрос.</a:t>
+              <a:t>Изменения приложения проходят path policy, Docker-проверки и review.</a:t>
             </a:r>
           </a:p>
           <a:p xmlns:a="http://schemas.openxmlformats.org/drawingml/2006/main">
@@ -11233,7 +11138,7 @@
                 <a:ea typeface="Helvetica Neue"/>
                 <a:cs typeface="Helvetica Neue"/>
               </a:rPr>
-              <a:t>После перезапуска CLI задача продолжается с того же шага.</a:t>
+              <a:t>Модель не делает commit и push.</a:t>
             </a:r>
           </a:p>
         </p:txBody>
@@ -11293,7 +11198,7 @@
                 <a:ea typeface="Helvetica Neue"/>
                 <a:cs typeface="Helvetica Neue"/>
               </a:rPr>
-              <a:t>Точечное одобрение</a:t>
+              <a:t>Protected patch</a:t>
             </a:r>
           </a:p>
           <a:p xmlns:a="http://schemas.openxmlformats.org/drawingml/2006/main">
@@ -11320,61 +11225,7 @@
                 <a:ea typeface="Helvetica Neue"/>
                 <a:cs typeface="Helvetica Neue"/>
               </a:rPr>
-              <a:t>Связано с запуском, операцией, SHA-256 патча и списком путей. Срок — один час.</a:t>
-            </a:r>
-          </a:p>
-          <a:p xmlns:a="http://schemas.openxmlformats.org/drawingml/2006/main">
-            <a:pPr algn="l">
-              <a:lnSpc>
-                <a:spcPct val="114000"/>
-              </a:lnSpc>
-              <a:spcAft>
-                <a:spcPts val="800"/>
-              </a:spcAft>
-              <a:buNone/>
-              <a:defRPr sz="2400">
-                <a:solidFill>
-                  <a:srgbClr val="000000"/>
-                </a:solidFill>
-                <a:latin typeface="Helvetica Neue"/>
-                <a:ea typeface="Helvetica Neue"/>
-                <a:cs typeface="Helvetica Neue"/>
-              </a:defRPr>
-            </a:pPr>
-            <a:r>
-              <a:rPr sz="1600">
-                <a:latin typeface="Helvetica Neue"/>
-                <a:ea typeface="Helvetica Neue"/>
-                <a:cs typeface="Helvetica Neue"/>
-              </a:rPr>
-              <a:t/>
-            </a:r>
-          </a:p>
-          <a:p xmlns:a="http://schemas.openxmlformats.org/drawingml/2006/main">
-            <a:pPr algn="l">
-              <a:lnSpc>
-                <a:spcPct val="114000"/>
-              </a:lnSpc>
-              <a:spcAft>
-                <a:spcPts val="800"/>
-              </a:spcAft>
-              <a:buNone/>
-              <a:defRPr sz="2400">
-                <a:solidFill>
-                  <a:srgbClr val="000000"/>
-                </a:solidFill>
-                <a:latin typeface="Helvetica Neue"/>
-                <a:ea typeface="Helvetica Neue"/>
-                <a:cs typeface="Helvetica Neue"/>
-              </a:defRPr>
-            </a:pPr>
-            <a:r>
-              <a:rPr sz="1600">
-                <a:latin typeface="Helvetica Neue"/>
-                <a:ea typeface="Helvetica Neue"/>
-                <a:cs typeface="Helvetica Neue"/>
-              </a:rPr>
-              <a:t>Отказ или истечение срока не выполняет защищённое действие.</a:t>
+              <a:t>Dependencies, native files, CI и конфигурация требуют одобрения точного hash и списка путей.</a:t>
             </a:r>
           </a:p>
         </p:txBody>

</xml_diff>